<commit_message>
Add the live Cloud Run URL to the README top and the deck closing slide
Deployed and verified: https://karnadhar-117722238113.asia-south1.run.app
(logo, 5 scenarios, deep-dive, real data all serving correctly).
</commit_message>
<xml_diff>
--- a/deliverables/KARNADHAR_Deck.pptx
+++ b/deliverables/KARNADHAR_Deck.pptx
@@ -4756,7 +4756,74 @@
         </p:nvSpPr>
         <p:spPr>
           <a:xfrm>
-            <a:off x="640080" y="5989320"/>
+            <a:off x="640080" y="5623560"/>
+            <a:ext cx="10881360" cy="320040"/>
+          </a:xfrm>
+          <a:prstGeom prst="rect">
+            <a:avLst/>
+          </a:prstGeom>
+          <a:noFill/>
+          <a:ln/>
+        </p:spPr>
+        <p:txBody>
+          <a:bodyPr wrap="square" lIns="0" tIns="0" rIns="0" bIns="0" rtlCol="0" anchor="ctr"/>
+          <a:lstStyle/>
+          <a:p>
+            <a:pPr indent="0" marL="0">
+              <a:buNone/>
+            </a:pPr>
+            <a:r>
+              <a:rPr lang="en-US" sz="1300" dirty="0">
+                <a:solidFill>
+                  <a:srgbClr val="93A0B0"/>
+                </a:solidFill>
+                <a:latin typeface="Arial" pitchFamily="34" charset="0"/>
+                <a:ea typeface="Arial" pitchFamily="34" charset="-122"/>
+                <a:cs typeface="Arial" pitchFamily="34" charset="-120"/>
+              </a:rPr>
+              <a:t>Live: </a:t>
+            </a:r>
+            <a:pPr indent="0" marL="0">
+              <a:buNone/>
+            </a:pPr>
+            <a:r>
+              <a:rPr lang="en-US" sz="1300" b="1" dirty="0">
+                <a:solidFill>
+                  <a:srgbClr val="5DCAA5"/>
+                </a:solidFill>
+                <a:latin typeface="Arial" pitchFamily="34" charset="0"/>
+                <a:ea typeface="Arial" pitchFamily="34" charset="-122"/>
+                <a:cs typeface="Arial" pitchFamily="34" charset="-120"/>
+              </a:rPr>
+              <a:t>karnadhar-117722238113.asia-south1.run.app</a:t>
+            </a:r>
+            <a:pPr indent="0" marL="0">
+              <a:buNone/>
+            </a:pPr>
+            <a:r>
+              <a:rPr lang="en-US" sz="1300" dirty="0">
+                <a:solidFill>
+                  <a:srgbClr val="93A0B0"/>
+                </a:solidFill>
+                <a:latin typeface="Arial" pitchFamily="34" charset="0"/>
+                <a:ea typeface="Arial" pitchFamily="34" charset="-122"/>
+                <a:cs typeface="Arial" pitchFamily="34" charset="-120"/>
+              </a:rPr>
+              <a:t>   ·   github.com/PureGenius369/Karnadhar</a:t>
+            </a:r>
+            <a:endParaRPr lang="en-US" sz="1300" dirty="0"/>
+          </a:p>
+        </p:txBody>
+      </p:sp>
+      <p:sp>
+        <p:nvSpPr>
+          <p:cNvPr id="8" name="Text 5"/>
+          <p:cNvSpPr/>
+          <p:nvPr/>
+        </p:nvSpPr>
+        <p:spPr>
+          <a:xfrm>
+            <a:off x="640080" y="6035040"/>
             <a:ext cx="10881360" cy="365760"/>
           </a:xfrm>
           <a:prstGeom prst="rect">

</xml_diff>